<commit_message>
Added a new slide to include relevant links
</commit_message>
<xml_diff>
--- a/Group A Presentation.pptx
+++ b/Group A Presentation.pptx
@@ -5,16 +5,17 @@
     <p:sldMasterId id="2147483666" r:id="rId4"/>
   </p:sldMasterIdLst>
   <p:notesMasterIdLst>
-    <p:notesMasterId r:id="rId9"/>
+    <p:notesMasterId r:id="rId10"/>
   </p:notesMasterIdLst>
   <p:handoutMasterIdLst>
-    <p:handoutMasterId r:id="rId10"/>
+    <p:handoutMasterId r:id="rId11"/>
   </p:handoutMasterIdLst>
   <p:sldIdLst>
     <p:sldId id="256" r:id="rId5"/>
     <p:sldId id="277" r:id="rId6"/>
     <p:sldId id="264" r:id="rId7"/>
     <p:sldId id="276" r:id="rId8"/>
+    <p:sldId id="278" r:id="rId9"/>
   </p:sldIdLst>
   <p:sldSz cx="12192000" cy="6858000"/>
   <p:notesSz cx="6858000" cy="9144000"/>
@@ -147,12 +148,20 @@
 </p:cmAuthorLst>
 </file>
 
+<file path=ppt/revisionInfo.xml><?xml version="1.0" encoding="utf-8"?>
+<p1510:revInfo xmlns:a="http://schemas.openxmlformats.org/drawingml/2006/main" xmlns:r="http://schemas.openxmlformats.org/officeDocument/2006/relationships" xmlns:p1510="http://schemas.microsoft.com/office/powerpoint/2015/10/main">
+  <p1510:revLst>
+    <p1510:client id="{CF03FCF6-7598-4B90-AF3F-90A325291D85}" v="3" dt="2026-03-26T13:46:02.781"/>
+  </p1510:revLst>
+</p1510:revInfo>
+</file>
+
 <file path=ppt/changesInfos/changesInfo1.xml><?xml version="1.0" encoding="utf-8"?>
 <pc:chgInfo xmlns:a="http://schemas.openxmlformats.org/drawingml/2006/main" xmlns:r="http://schemas.openxmlformats.org/officeDocument/2006/relationships" xmlns:ac="http://schemas.microsoft.com/office/drawing/2013/main/command" xmlns:pc="http://schemas.microsoft.com/office/powerpoint/2013/main/command">
   <pc:docChgLst>
     <pc:chgData name="Richard Badea" userId="07c04ef0-c08c-4801-9d58-0bd6cd9d1bec" providerId="ADAL" clId="{2FD2290B-C2BF-4F69-B8F8-6CE6D96C7FD1}"/>
-    <pc:docChg chg="custSel modSld">
-      <pc:chgData name="Richard Badea" userId="07c04ef0-c08c-4801-9d58-0bd6cd9d1bec" providerId="ADAL" clId="{2FD2290B-C2BF-4F69-B8F8-6CE6D96C7FD1}" dt="2026-03-25T12:05:12.383" v="19" actId="207"/>
+    <pc:docChg chg="custSel addSld delSld modSld">
+      <pc:chgData name="Richard Badea" userId="07c04ef0-c08c-4801-9d58-0bd6cd9d1bec" providerId="ADAL" clId="{2FD2290B-C2BF-4F69-B8F8-6CE6D96C7FD1}" dt="2026-03-26T13:48:50.473" v="93" actId="20577"/>
       <pc:docMkLst>
         <pc:docMk/>
       </pc:docMkLst>
@@ -178,6 +187,52 @@
             <ac:spMk id="5" creationId="{0DFADE42-1A3F-40C8-A071-E57644F3D843}"/>
           </ac:spMkLst>
         </pc:spChg>
+      </pc:sldChg>
+      <pc:sldChg chg="modSp new mod">
+        <pc:chgData name="Richard Badea" userId="07c04ef0-c08c-4801-9d58-0bd6cd9d1bec" providerId="ADAL" clId="{2FD2290B-C2BF-4F69-B8F8-6CE6D96C7FD1}" dt="2026-03-26T13:48:50.473" v="93" actId="20577"/>
+        <pc:sldMkLst>
+          <pc:docMk/>
+          <pc:sldMk cId="2374496461" sldId="278"/>
+        </pc:sldMkLst>
+        <pc:spChg chg="mod">
+          <ac:chgData name="Richard Badea" userId="07c04ef0-c08c-4801-9d58-0bd6cd9d1bec" providerId="ADAL" clId="{2FD2290B-C2BF-4F69-B8F8-6CE6D96C7FD1}" dt="2026-03-26T13:44:41.493" v="41" actId="20577"/>
+          <ac:spMkLst>
+            <pc:docMk/>
+            <pc:sldMk cId="2374496461" sldId="278"/>
+            <ac:spMk id="2" creationId="{923686B5-6AEE-B07F-C3C3-FB9073A80F5C}"/>
+          </ac:spMkLst>
+        </pc:spChg>
+        <pc:spChg chg="mod">
+          <ac:chgData name="Richard Badea" userId="07c04ef0-c08c-4801-9d58-0bd6cd9d1bec" providerId="ADAL" clId="{2FD2290B-C2BF-4F69-B8F8-6CE6D96C7FD1}" dt="2026-03-26T13:48:01.477" v="73" actId="20577"/>
+          <ac:spMkLst>
+            <pc:docMk/>
+            <pc:sldMk cId="2374496461" sldId="278"/>
+            <ac:spMk id="3" creationId="{786DC601-11DD-CB5D-4DEC-4B9C2F3EB734}"/>
+          </ac:spMkLst>
+        </pc:spChg>
+        <pc:spChg chg="mod">
+          <ac:chgData name="Richard Badea" userId="07c04ef0-c08c-4801-9d58-0bd6cd9d1bec" providerId="ADAL" clId="{2FD2290B-C2BF-4F69-B8F8-6CE6D96C7FD1}" dt="2026-03-26T13:48:24.767" v="82" actId="20577"/>
+          <ac:spMkLst>
+            <pc:docMk/>
+            <pc:sldMk cId="2374496461" sldId="278"/>
+            <ac:spMk id="4" creationId="{EC0B0605-D9D3-5AA9-92EC-887DCE869A6E}"/>
+          </ac:spMkLst>
+        </pc:spChg>
+        <pc:spChg chg="mod">
+          <ac:chgData name="Richard Badea" userId="07c04ef0-c08c-4801-9d58-0bd6cd9d1bec" providerId="ADAL" clId="{2FD2290B-C2BF-4F69-B8F8-6CE6D96C7FD1}" dt="2026-03-26T13:48:50.473" v="93" actId="20577"/>
+          <ac:spMkLst>
+            <pc:docMk/>
+            <pc:sldMk cId="2374496461" sldId="278"/>
+            <ac:spMk id="5" creationId="{C58C9315-2E53-C158-EB93-4ECF11812D93}"/>
+          </ac:spMkLst>
+        </pc:spChg>
+      </pc:sldChg>
+      <pc:sldChg chg="new del">
+        <pc:chgData name="Richard Badea" userId="07c04ef0-c08c-4801-9d58-0bd6cd9d1bec" providerId="ADAL" clId="{2FD2290B-C2BF-4F69-B8F8-6CE6D96C7FD1}" dt="2026-03-26T13:44:21.766" v="21" actId="2696"/>
+        <pc:sldMkLst>
+          <pc:docMk/>
+          <pc:sldMk cId="2745743161" sldId="278"/>
+        </pc:sldMkLst>
       </pc:sldChg>
     </pc:docChg>
   </pc:docChgLst>
@@ -278,7 +333,7 @@
           <a:p>
             <a:fld id="{F352A77B-D33C-49B3-A83C-450AA2ED72B3}" type="datetimeFigureOut">
               <a:rPr lang="en-US" smtClean="0"/>
-              <a:t>3/25/2026</a:t>
+              <a:t>3/26/2026</a:t>
             </a:fld>
             <a:endParaRPr lang="en-US" dirty="0"/>
           </a:p>
@@ -455,7 +510,7 @@
           <a:p>
             <a:fld id="{E38D8F9A-F5CB-4EF8-A859-ED5E107B9763}" type="datetimeFigureOut">
               <a:rPr lang="en-US" smtClean="0"/>
-              <a:t>3/25/2026</a:t>
+              <a:t>3/26/2026</a:t>
             </a:fld>
             <a:endParaRPr lang="en-US" dirty="0"/>
           </a:p>
@@ -890,10 +945,10 @@
           <p:nvPr/>
         </p:nvPicPr>
         <p:blipFill rotWithShape="1">
-          <a:blip r:embed="rId2">
+          <a:blip>
             <a:extLst>
               <a:ext uri="{96DAC541-7B7A-43D3-8B79-37D633B846F1}">
-                <asvg:svgBlip xmlns:asvg="http://schemas.microsoft.com/office/drawing/2016/SVG/main" r:embed="rId3"/>
+                <asvg:svgBlip xmlns:asvg="http://schemas.microsoft.com/office/drawing/2016/SVG/main" r:embed="rId2"/>
               </a:ext>
             </a:extLst>
           </a:blip>
@@ -1549,10 +1604,10 @@
           <p:nvPr userDrawn="1"/>
         </p:nvPicPr>
         <p:blipFill>
-          <a:blip r:embed="rId2">
+          <a:blip>
             <a:extLst>
               <a:ext uri="{96DAC541-7B7A-43D3-8B79-37D633B846F1}">
-                <asvg:svgBlip xmlns:asvg="http://schemas.microsoft.com/office/drawing/2016/SVG/main" r:embed="rId3"/>
+                <asvg:svgBlip xmlns:asvg="http://schemas.microsoft.com/office/drawing/2016/SVG/main" r:embed="rId2"/>
               </a:ext>
             </a:extLst>
           </a:blip>
@@ -1588,10 +1643,10 @@
           <p:nvPr userDrawn="1"/>
         </p:nvPicPr>
         <p:blipFill>
-          <a:blip r:embed="rId4">
+          <a:blip>
             <a:extLst>
               <a:ext uri="{96DAC541-7B7A-43D3-8B79-37D633B846F1}">
-                <asvg:svgBlip xmlns:asvg="http://schemas.microsoft.com/office/drawing/2016/SVG/main" r:embed="rId5"/>
+                <asvg:svgBlip xmlns:asvg="http://schemas.microsoft.com/office/drawing/2016/SVG/main" r:embed="rId3"/>
               </a:ext>
             </a:extLst>
           </a:blip>
@@ -1627,10 +1682,10 @@
           <p:nvPr userDrawn="1"/>
         </p:nvPicPr>
         <p:blipFill>
-          <a:blip r:embed="rId6">
+          <a:blip>
             <a:extLst>
               <a:ext uri="{96DAC541-7B7A-43D3-8B79-37D633B846F1}">
-                <asvg:svgBlip xmlns:asvg="http://schemas.microsoft.com/office/drawing/2016/SVG/main" r:embed="rId7"/>
+                <asvg:svgBlip xmlns:asvg="http://schemas.microsoft.com/office/drawing/2016/SVG/main" r:embed="rId4"/>
               </a:ext>
             </a:extLst>
           </a:blip>
@@ -2684,10 +2739,10 @@
           <p:nvPr/>
         </p:nvPicPr>
         <p:blipFill rotWithShape="1">
-          <a:blip r:embed="rId2">
+          <a:blip>
             <a:extLst>
               <a:ext uri="{96DAC541-7B7A-43D3-8B79-37D633B846F1}">
-                <asvg:svgBlip xmlns:asvg="http://schemas.microsoft.com/office/drawing/2016/SVG/main" r:embed="rId3"/>
+                <asvg:svgBlip xmlns:asvg="http://schemas.microsoft.com/office/drawing/2016/SVG/main" r:embed="rId2"/>
               </a:ext>
             </a:extLst>
           </a:blip>
@@ -2752,10 +2807,10 @@
           <p:nvPr userDrawn="1"/>
         </p:nvPicPr>
         <p:blipFill rotWithShape="1">
-          <a:blip r:embed="rId2">
+          <a:blip>
             <a:extLst>
               <a:ext uri="{96DAC541-7B7A-43D3-8B79-37D633B846F1}">
-                <asvg:svgBlip xmlns:asvg="http://schemas.microsoft.com/office/drawing/2016/SVG/main" r:embed="rId3"/>
+                <asvg:svgBlip xmlns:asvg="http://schemas.microsoft.com/office/drawing/2016/SVG/main" r:embed="rId2"/>
               </a:ext>
             </a:extLst>
           </a:blip>
@@ -8350,10 +8405,10 @@
           <p:nvPr/>
         </p:nvPicPr>
         <p:blipFill>
-          <a:blip r:embed="rId2">
+          <a:blip>
             <a:extLst>
               <a:ext uri="{96DAC541-7B7A-43D3-8B79-37D633B846F1}">
-                <asvg:svgBlip xmlns:asvg="http://schemas.microsoft.com/office/drawing/2016/SVG/main" r:embed="rId3"/>
+                <asvg:svgBlip xmlns:asvg="http://schemas.microsoft.com/office/drawing/2016/SVG/main" r:embed="rId2"/>
               </a:ext>
             </a:extLst>
           </a:blip>
@@ -8389,10 +8444,10 @@
           <p:nvPr/>
         </p:nvPicPr>
         <p:blipFill>
-          <a:blip r:embed="rId4">
+          <a:blip>
             <a:extLst>
               <a:ext uri="{96DAC541-7B7A-43D3-8B79-37D633B846F1}">
-                <asvg:svgBlip xmlns:asvg="http://schemas.microsoft.com/office/drawing/2016/SVG/main" r:embed="rId5"/>
+                <asvg:svgBlip xmlns:asvg="http://schemas.microsoft.com/office/drawing/2016/SVG/main" r:embed="rId3"/>
               </a:ext>
             </a:extLst>
           </a:blip>
@@ -10511,10 +10566,10 @@
           <p:nvPr/>
         </p:nvPicPr>
         <p:blipFill>
-          <a:blip r:embed="rId2">
+          <a:blip>
             <a:extLst>
               <a:ext uri="{96DAC541-7B7A-43D3-8B79-37D633B846F1}">
-                <asvg:svgBlip xmlns:asvg="http://schemas.microsoft.com/office/drawing/2016/SVG/main" r:embed="rId3"/>
+                <asvg:svgBlip xmlns:asvg="http://schemas.microsoft.com/office/drawing/2016/SVG/main" r:embed="rId2"/>
               </a:ext>
             </a:extLst>
           </a:blip>
@@ -10697,10 +10752,10 @@
           <p:nvPr/>
         </p:nvPicPr>
         <p:blipFill rotWithShape="1">
-          <a:blip r:embed="rId2">
+          <a:blip>
             <a:extLst>
               <a:ext uri="{96DAC541-7B7A-43D3-8B79-37D633B846F1}">
-                <asvg:svgBlip xmlns:asvg="http://schemas.microsoft.com/office/drawing/2016/SVG/main" r:embed="rId3"/>
+                <asvg:svgBlip xmlns:asvg="http://schemas.microsoft.com/office/drawing/2016/SVG/main" r:embed="rId2"/>
               </a:ext>
             </a:extLst>
           </a:blip>
@@ -12597,10 +12652,10 @@
           <p:nvPr userDrawn="1"/>
         </p:nvPicPr>
         <p:blipFill>
-          <a:blip r:embed="rId2">
+          <a:blip>
             <a:extLst>
               <a:ext uri="{96DAC541-7B7A-43D3-8B79-37D633B846F1}">
-                <asvg:svgBlip xmlns:asvg="http://schemas.microsoft.com/office/drawing/2016/SVG/main" r:embed="rId3"/>
+                <asvg:svgBlip xmlns:asvg="http://schemas.microsoft.com/office/drawing/2016/SVG/main" r:embed="rId2"/>
               </a:ext>
             </a:extLst>
           </a:blip>
@@ -12636,10 +12691,10 @@
           <p:nvPr userDrawn="1"/>
         </p:nvPicPr>
         <p:blipFill>
-          <a:blip r:embed="rId4">
+          <a:blip>
             <a:extLst>
               <a:ext uri="{96DAC541-7B7A-43D3-8B79-37D633B846F1}">
-                <asvg:svgBlip xmlns:asvg="http://schemas.microsoft.com/office/drawing/2016/SVG/main" r:embed="rId5"/>
+                <asvg:svgBlip xmlns:asvg="http://schemas.microsoft.com/office/drawing/2016/SVG/main" r:embed="rId3"/>
               </a:ext>
             </a:extLst>
           </a:blip>
@@ -13287,10 +13342,10 @@
           <p:nvPr userDrawn="1"/>
         </p:nvPicPr>
         <p:blipFill rotWithShape="1">
-          <a:blip r:embed="rId2">
+          <a:blip>
             <a:extLst>
               <a:ext uri="{96DAC541-7B7A-43D3-8B79-37D633B846F1}">
-                <asvg:svgBlip xmlns:asvg="http://schemas.microsoft.com/office/drawing/2016/SVG/main" r:embed="rId3"/>
+                <asvg:svgBlip xmlns:asvg="http://schemas.microsoft.com/office/drawing/2016/SVG/main" r:embed="rId2"/>
               </a:ext>
             </a:extLst>
           </a:blip>
@@ -13822,10 +13877,10 @@
           <p:nvPr/>
         </p:nvPicPr>
         <p:blipFill>
-          <a:blip r:embed="rId2">
+          <a:blip>
             <a:extLst>
               <a:ext uri="{96DAC541-7B7A-43D3-8B79-37D633B846F1}">
-                <asvg:svgBlip xmlns:asvg="http://schemas.microsoft.com/office/drawing/2016/SVG/main" r:embed="rId3"/>
+                <asvg:svgBlip xmlns:asvg="http://schemas.microsoft.com/office/drawing/2016/SVG/main" r:embed="rId2"/>
               </a:ext>
             </a:extLst>
           </a:blip>
@@ -13888,10 +13943,10 @@
           <p:nvPr/>
         </p:nvPicPr>
         <p:blipFill>
-          <a:blip r:embed="rId2">
+          <a:blip>
             <a:extLst>
               <a:ext uri="{96DAC541-7B7A-43D3-8B79-37D633B846F1}">
-                <asvg:svgBlip xmlns:asvg="http://schemas.microsoft.com/office/drawing/2016/SVG/main" r:embed="rId3"/>
+                <asvg:svgBlip xmlns:asvg="http://schemas.microsoft.com/office/drawing/2016/SVG/main" r:embed="rId2"/>
               </a:ext>
             </a:extLst>
           </a:blip>
@@ -16835,6 +16890,200 @@
     <p:extLst>
       <p:ext uri="{BB962C8B-B14F-4D97-AF65-F5344CB8AC3E}">
         <p14:creationId xmlns:p14="http://schemas.microsoft.com/office/powerpoint/2010/main" val="2436493926"/>
+      </p:ext>
+    </p:extLst>
+  </p:cSld>
+  <p:clrMapOvr>
+    <a:masterClrMapping/>
+  </p:clrMapOvr>
+</p:sld>
+</file>
+
+<file path=ppt/slides/slide5.xml><?xml version="1.0" encoding="utf-8"?>
+<p:sld xmlns:a="http://schemas.openxmlformats.org/drawingml/2006/main" xmlns:r="http://schemas.openxmlformats.org/officeDocument/2006/relationships" xmlns:p="http://schemas.openxmlformats.org/presentationml/2006/main">
+  <p:cSld>
+    <p:spTree>
+      <p:nvGrpSpPr>
+        <p:cNvPr id="1" name=""/>
+        <p:cNvGrpSpPr/>
+        <p:nvPr/>
+      </p:nvGrpSpPr>
+      <p:grpSpPr>
+        <a:xfrm>
+          <a:off x="0" y="0"/>
+          <a:ext cx="0" cy="0"/>
+          <a:chOff x="0" y="0"/>
+          <a:chExt cx="0" cy="0"/>
+        </a:xfrm>
+      </p:grpSpPr>
+      <p:sp>
+        <p:nvSpPr>
+          <p:cNvPr id="2" name="Title 1">
+            <a:extLst>
+              <a:ext uri="{FF2B5EF4-FFF2-40B4-BE49-F238E27FC236}">
+                <a16:creationId xmlns:a16="http://schemas.microsoft.com/office/drawing/2014/main" id="{923686B5-6AEE-B07F-C3C3-FB9073A80F5C}"/>
+              </a:ext>
+            </a:extLst>
+          </p:cNvPr>
+          <p:cNvSpPr>
+            <a:spLocks noGrp="1"/>
+          </p:cNvSpPr>
+          <p:nvPr>
+            <p:ph type="title"/>
+          </p:nvPr>
+        </p:nvSpPr>
+        <p:spPr/>
+        <p:txBody>
+          <a:bodyPr/>
+          <a:lstStyle/>
+          <a:p>
+            <a:r>
+              <a:rPr lang="en-US" dirty="0"/>
+              <a:t>Appropriate Links</a:t>
+            </a:r>
+            <a:endParaRPr lang="en-GB" dirty="0"/>
+          </a:p>
+        </p:txBody>
+      </p:sp>
+      <p:sp>
+        <p:nvSpPr>
+          <p:cNvPr id="3" name="Text Placeholder 2">
+            <a:extLst>
+              <a:ext uri="{FF2B5EF4-FFF2-40B4-BE49-F238E27FC236}">
+                <a16:creationId xmlns:a16="http://schemas.microsoft.com/office/drawing/2014/main" id="{786DC601-11DD-CB5D-4DEC-4B9C2F3EB734}"/>
+              </a:ext>
+            </a:extLst>
+          </p:cNvPr>
+          <p:cNvSpPr>
+            <a:spLocks noGrp="1"/>
+          </p:cNvSpPr>
+          <p:nvPr>
+            <p:ph type="body" idx="1"/>
+          </p:nvPr>
+        </p:nvSpPr>
+        <p:spPr/>
+        <p:txBody>
+          <a:bodyPr/>
+          <a:lstStyle/>
+          <a:p>
+            <a:r>
+              <a:rPr lang="en-US" dirty="0"/>
+              <a:t>GitHub-</a:t>
+            </a:r>
+            <a:r>
+              <a:rPr lang="en-US" dirty="0">
+                <a:hlinkClick r:id="rId2"/>
+              </a:rPr>
+              <a:t>https://github.com/X24378823/SE-Project-Repo</a:t>
+            </a:r>
+            <a:endParaRPr lang="en-US" dirty="0"/>
+          </a:p>
+          <a:p>
+            <a:endParaRPr lang="en-US" dirty="0"/>
+          </a:p>
+          <a:p>
+            <a:r>
+              <a:rPr lang="en-US" dirty="0"/>
+              <a:t>Teams Video-</a:t>
+            </a:r>
+            <a:endParaRPr lang="en-GB" dirty="0"/>
+          </a:p>
+        </p:txBody>
+      </p:sp>
+      <p:sp>
+        <p:nvSpPr>
+          <p:cNvPr id="4" name="Date Placeholder 3">
+            <a:extLst>
+              <a:ext uri="{FF2B5EF4-FFF2-40B4-BE49-F238E27FC236}">
+                <a16:creationId xmlns:a16="http://schemas.microsoft.com/office/drawing/2014/main" id="{EC0B0605-D9D3-5AA9-92EC-887DCE869A6E}"/>
+              </a:ext>
+            </a:extLst>
+          </p:cNvPr>
+          <p:cNvSpPr>
+            <a:spLocks noGrp="1"/>
+          </p:cNvSpPr>
+          <p:nvPr>
+            <p:ph type="dt" sz="half" idx="10"/>
+          </p:nvPr>
+        </p:nvSpPr>
+        <p:spPr/>
+        <p:txBody>
+          <a:bodyPr/>
+          <a:lstStyle/>
+          <a:p>
+            <a:r>
+              <a:rPr lang="en-US" sz="1400" dirty="0"/>
+              <a:t>2026</a:t>
+            </a:r>
+          </a:p>
+        </p:txBody>
+      </p:sp>
+      <p:sp>
+        <p:nvSpPr>
+          <p:cNvPr id="5" name="Footer Placeholder 4">
+            <a:extLst>
+              <a:ext uri="{FF2B5EF4-FFF2-40B4-BE49-F238E27FC236}">
+                <a16:creationId xmlns:a16="http://schemas.microsoft.com/office/drawing/2014/main" id="{C58C9315-2E53-C158-EB93-4ECF11812D93}"/>
+              </a:ext>
+            </a:extLst>
+          </p:cNvPr>
+          <p:cNvSpPr>
+            <a:spLocks noGrp="1"/>
+          </p:cNvSpPr>
+          <p:nvPr>
+            <p:ph type="ftr" sz="quarter" idx="11"/>
+          </p:nvPr>
+        </p:nvSpPr>
+        <p:spPr/>
+        <p:txBody>
+          <a:bodyPr/>
+          <a:lstStyle/>
+          <a:p>
+            <a:r>
+              <a:rPr lang="en-US" sz="1400" dirty="0">
+                <a:solidFill>
+                  <a:schemeClr val="tx1"/>
+                </a:solidFill>
+                <a:latin typeface="Abadi" panose="020B0604020104020204" pitchFamily="34" charset="0"/>
+              </a:rPr>
+              <a:t>Group A</a:t>
+            </a:r>
+          </a:p>
+        </p:txBody>
+      </p:sp>
+      <p:sp>
+        <p:nvSpPr>
+          <p:cNvPr id="6" name="Slide Number Placeholder 5">
+            <a:extLst>
+              <a:ext uri="{FF2B5EF4-FFF2-40B4-BE49-F238E27FC236}">
+                <a16:creationId xmlns:a16="http://schemas.microsoft.com/office/drawing/2014/main" id="{180C7269-A443-319B-CC50-21D1F4316438}"/>
+              </a:ext>
+            </a:extLst>
+          </p:cNvPr>
+          <p:cNvSpPr>
+            <a:spLocks noGrp="1"/>
+          </p:cNvSpPr>
+          <p:nvPr>
+            <p:ph type="sldNum" sz="quarter" idx="12"/>
+          </p:nvPr>
+        </p:nvSpPr>
+        <p:spPr/>
+        <p:txBody>
+          <a:bodyPr/>
+          <a:lstStyle/>
+          <a:p>
+            <a:fld id="{B5CEABB6-07DC-46E8-9B57-56EC44A396E5}" type="slidenum">
+              <a:rPr lang="en-US" smtClean="0"/>
+              <a:t>5</a:t>
+            </a:fld>
+            <a:endParaRPr lang="en-US" dirty="0"/>
+          </a:p>
+        </p:txBody>
+      </p:sp>
+    </p:spTree>
+    <p:extLst>
+      <p:ext uri="{BB962C8B-B14F-4D97-AF65-F5344CB8AC3E}">
+        <p14:creationId xmlns:p14="http://schemas.microsoft.com/office/powerpoint/2010/main" val="2374496461"/>
       </p:ext>
     </p:extLst>
   </p:cSld>
@@ -17636,23 +17885,12 @@
 </file>
 
 <file path=customXml/item1.xml><?xml version="1.0" encoding="utf-8"?>
-<p:properties xmlns:p="http://schemas.microsoft.com/office/2006/metadata/properties" xmlns:xsi="http://www.w3.org/2001/XMLSchema-instance" xmlns:pc="http://schemas.microsoft.com/office/infopath/2007/PartnerControls">
-  <documentManagement>
-    <_ip_UnifiedCompliancePolicyUIAction xmlns="http://schemas.microsoft.com/sharepoint/v3" xsi:nil="true"/>
-    <Image xmlns="71af3243-3dd4-4a8d-8c0d-dd76da1f02a5">
-      <Url xsi:nil="true"/>
-      <Description xsi:nil="true"/>
-    </Image>
-    <Status xmlns="71af3243-3dd4-4a8d-8c0d-dd76da1f02a5">Not started</Status>
-    <Background xmlns="71af3243-3dd4-4a8d-8c0d-dd76da1f02a5">false</Background>
-    <_ip_UnifiedCompliancePolicyProperties xmlns="http://schemas.microsoft.com/sharepoint/v3" xsi:nil="true"/>
-    <ImageTagsTaxHTField xmlns="71af3243-3dd4-4a8d-8c0d-dd76da1f02a5">
-      <Terms xmlns="http://schemas.microsoft.com/office/infopath/2007/PartnerControls"/>
-    </ImageTagsTaxHTField>
-    <TaxCatchAll xmlns="230e9df3-be65-4c73-a93b-d1236ebd677e" xsi:nil="true"/>
-    <MediaServiceKeyPoints xmlns="71af3243-3dd4-4a8d-8c0d-dd76da1f02a5" xsi:nil="true"/>
-  </documentManagement>
-</p:properties>
+<?mso-contentType ?>
+<FormTemplates xmlns="http://schemas.microsoft.com/sharepoint/v3/contenttype/forms">
+  <Display>DocumentLibraryForm</Display>
+  <Edit>DocumentLibraryForm</Edit>
+  <New>DocumentLibraryForm</New>
+</FormTemplates>
 </file>
 
 <file path=customXml/item2.xml><?xml version="1.0" encoding="utf-8"?>
@@ -17962,22 +18200,29 @@
 </file>
 
 <file path=customXml/item3.xml><?xml version="1.0" encoding="utf-8"?>
-<?mso-contentType ?>
-<FormTemplates xmlns="http://schemas.microsoft.com/sharepoint/v3/contenttype/forms">
-  <Display>DocumentLibraryForm</Display>
-  <Edit>DocumentLibraryForm</Edit>
-  <New>DocumentLibraryForm</New>
-</FormTemplates>
+<p:properties xmlns:p="http://schemas.microsoft.com/office/2006/metadata/properties" xmlns:xsi="http://www.w3.org/2001/XMLSchema-instance" xmlns:pc="http://schemas.microsoft.com/office/infopath/2007/PartnerControls">
+  <documentManagement>
+    <_ip_UnifiedCompliancePolicyUIAction xmlns="http://schemas.microsoft.com/sharepoint/v3" xsi:nil="true"/>
+    <Image xmlns="71af3243-3dd4-4a8d-8c0d-dd76da1f02a5">
+      <Url xsi:nil="true"/>
+      <Description xsi:nil="true"/>
+    </Image>
+    <Status xmlns="71af3243-3dd4-4a8d-8c0d-dd76da1f02a5">Not started</Status>
+    <Background xmlns="71af3243-3dd4-4a8d-8c0d-dd76da1f02a5">false</Background>
+    <_ip_UnifiedCompliancePolicyProperties xmlns="http://schemas.microsoft.com/sharepoint/v3" xsi:nil="true"/>
+    <ImageTagsTaxHTField xmlns="71af3243-3dd4-4a8d-8c0d-dd76da1f02a5">
+      <Terms xmlns="http://schemas.microsoft.com/office/infopath/2007/PartnerControls"/>
+    </ImageTagsTaxHTField>
+    <TaxCatchAll xmlns="230e9df3-be65-4c73-a93b-d1236ebd677e" xsi:nil="true"/>
+    <MediaServiceKeyPoints xmlns="71af3243-3dd4-4a8d-8c0d-dd76da1f02a5" xsi:nil="true"/>
+  </documentManagement>
+</p:properties>
 </file>
 
 <file path=customXml/itemProps1.xml><?xml version="1.0" encoding="utf-8"?>
-<ds:datastoreItem xmlns:ds="http://schemas.openxmlformats.org/officeDocument/2006/customXml" ds:itemID="{BEFFFA3F-0FB5-4ED3-8906-A15B16577F44}">
+<ds:datastoreItem xmlns:ds="http://schemas.openxmlformats.org/officeDocument/2006/customXml" ds:itemID="{6966C46A-DC57-4209-80CD-9FE6C93151FF}">
   <ds:schemaRefs>
-    <ds:schemaRef ds:uri="http://schemas.microsoft.com/office/2006/metadata/properties"/>
-    <ds:schemaRef ds:uri="http://schemas.microsoft.com/office/infopath/2007/PartnerControls"/>
-    <ds:schemaRef ds:uri="http://schemas.microsoft.com/sharepoint/v3"/>
-    <ds:schemaRef ds:uri="71af3243-3dd4-4a8d-8c0d-dd76da1f02a5"/>
-    <ds:schemaRef ds:uri="230e9df3-be65-4c73-a93b-d1236ebd677e"/>
+    <ds:schemaRef ds:uri="http://schemas.microsoft.com/sharepoint/v3/contenttype/forms"/>
   </ds:schemaRefs>
 </ds:datastoreItem>
 </file>
@@ -18004,9 +18249,13 @@
 </file>
 
 <file path=customXml/itemProps3.xml><?xml version="1.0" encoding="utf-8"?>
-<ds:datastoreItem xmlns:ds="http://schemas.openxmlformats.org/officeDocument/2006/customXml" ds:itemID="{6966C46A-DC57-4209-80CD-9FE6C93151FF}">
+<ds:datastoreItem xmlns:ds="http://schemas.openxmlformats.org/officeDocument/2006/customXml" ds:itemID="{BEFFFA3F-0FB5-4ED3-8906-A15B16577F44}">
   <ds:schemaRefs>
-    <ds:schemaRef ds:uri="http://schemas.microsoft.com/sharepoint/v3/contenttype/forms"/>
+    <ds:schemaRef ds:uri="http://schemas.microsoft.com/office/2006/metadata/properties"/>
+    <ds:schemaRef ds:uri="http://schemas.microsoft.com/office/infopath/2007/PartnerControls"/>
+    <ds:schemaRef ds:uri="http://schemas.microsoft.com/sharepoint/v3"/>
+    <ds:schemaRef ds:uri="71af3243-3dd4-4a8d-8c0d-dd76da1f02a5"/>
+    <ds:schemaRef ds:uri="230e9df3-be65-4c73-a93b-d1236ebd677e"/>
   </ds:schemaRefs>
 </ds:datastoreItem>
 </file>

</xml_diff>